<commit_message>
Reporte tecnico mas claro, pendiente: generar el pdf del documento tecnico y actualizacion de las estrategias por perfil
</commit_message>
<xml_diff>
--- a/DATA/DOCS/presentacion_ejecutiva.pptx
+++ b/DATA/DOCS/presentacion_ejecutiva.pptx
@@ -3375,7 +3375,7 @@
               </a:defRPr>
             </a:pPr>
             <a:r>
-              <a:t>6 perfiles estables (ARI 0.98) que capturan nivel Y forma de participación</a:t>
+              <a:t>6 perfiles que se reproducen casi idénticos y capturan cuánto y cómo vota la gente</a:t>
             </a:r>
           </a:p>
         </p:txBody>
@@ -3480,7 +3480,7 @@
               </a:defRPr>
             </a:pPr>
             <a:r>
-              <a:t>P1 (5.9M) es el único perfil en descenso: requiere intervención urgente</a:t>
+              <a:t>P1 (5.9M) es el único perfil en descenso: conviene intervenir pronto</a:t>
             </a:r>
           </a:p>
         </p:txBody>
@@ -3808,7 +3808,7 @@
               </a:defRPr>
             </a:pPr>
             <a:r>
-              <a:t>Las estrategias genéricas no funcionan</a:t>
+              <a:t>¿Qué tipos de ciudadanía existen según cómo participan?</a:t>
             </a:r>
           </a:p>
         </p:txBody>
@@ -5242,7 +5242,7 @@
               </a:defRPr>
             </a:pPr>
             <a:r>
-              <a:t>Metodología: Análisis de Clases Latentes</a:t>
+              <a:t>Metodología: cómo encontramos los perfiles</a:t>
             </a:r>
           </a:p>
         </p:txBody>
@@ -5321,7 +5321,7 @@
               </a:defRPr>
             </a:pPr>
             <a:r>
-              <a:t>1. Exploración</a:t>
+              <a:t>1. Lo que probamos</a:t>
             </a:r>
           </a:p>
         </p:txBody>
@@ -5356,19 +5356,23 @@
               </a:defRPr>
             </a:pPr>
             <a:r>
-              <a:t>2,000+ configuraciones</a:t>
+              <a:t>Más de 4,400 variantes</a:t>
             </a:r>
             <a:br/>
             <a:r>
-              <a:t>de clustering evaluadas</a:t>
+              <a:t>de agrupamiento:</a:t>
             </a:r>
             <a:br/>
             <a:r>
-              <a:t>(K-Means, GMM, Ward,</a:t>
+              <a:t>K-Means, mezclas,</a:t>
             </a:r>
             <a:br/>
             <a:r>
-              <a:t>HDBSCAN, espectral...)</a:t>
+              <a:t>jerárquico, densidad,</a:t>
+            </a:r>
+            <a:br/>
+            <a:r>
+              <a:t>UMAP y t-SNE</a:t>
             </a:r>
           </a:p>
         </p:txBody>
@@ -5447,7 +5451,7 @@
               </a:defRPr>
             </a:pPr>
             <a:r>
-              <a:t>2. Decisión</a:t>
+              <a:t>2. Lo que aprendimos</a:t>
             </a:r>
           </a:p>
         </p:txBody>
@@ -5482,19 +5486,27 @@
               </a:defRPr>
             </a:pPr>
             <a:r>
-              <a:t>Clustering clásico</a:t>
+              <a:t>Los métodos clásicos</a:t>
             </a:r>
             <a:br/>
             <a:r>
-              <a:t>separa por NIVEL</a:t>
+              <a:t>solo separan cuánto</a:t>
             </a:r>
             <a:br/>
             <a:r>
-              <a:t>(alto/medio/bajo).</a:t>
+              <a:t>vota la gente.</a:t>
             </a:r>
             <a:br/>
             <a:r>
-              <a:t>No captura la FORMA</a:t>
+              <a:t>No ven cómo vota:</a:t>
+            </a:r>
+            <a:br/>
+            <a:r>
+              <a:t>estable o solo en</a:t>
+            </a:r>
+            <a:br/>
+            <a:r>
+              <a:t>presidenciales</a:t>
             </a:r>
           </a:p>
         </p:txBody>
@@ -5573,7 +5585,7 @@
               </a:defRPr>
             </a:pPr>
             <a:r>
-              <a:t>3. LCA</a:t>
+              <a:t>3. Lo que elegimos</a:t>
             </a:r>
           </a:p>
         </p:txBody>
@@ -5608,19 +5620,31 @@
               </a:defRPr>
             </a:pPr>
             <a:r>
-              <a:t>Terciles por elección</a:t>
+              <a:t>Clases latentes:</a:t>
             </a:r>
             <a:br/>
             <a:r>
-              <a:t>+ mezcla categórica</a:t>
+              <a:t>cada elección se marca</a:t>
             </a:r>
             <a:br/>
             <a:r>
-              <a:t>con EM propio.</a:t>
+              <a:t>baja, media o alta</a:t>
             </a:r>
             <a:br/>
             <a:r>
-              <a:t>Captura nivel Y forma</a:t>
+              <a:t>frente al resto del país</a:t>
+            </a:r>
+            <a:br/>
+            <a:r>
+              <a:t>y el modelo agrupa</a:t>
+            </a:r>
+            <a:br/>
+            <a:r>
+              <a:t>los patrones que</a:t>
+            </a:r>
+            <a:br/>
+            <a:r>
+              <a:t>más se repiten</a:t>
             </a:r>
           </a:p>
         </p:txBody>
@@ -5699,7 +5723,7 @@
               </a:defRPr>
             </a:pPr>
             <a:r>
-              <a:t>4. Validación</a:t>
+              <a:t>4. Qué tan confiable</a:t>
             </a:r>
           </a:p>
         </p:txBody>
@@ -5734,19 +5758,35 @@
               </a:defRPr>
             </a:pPr>
             <a:r>
-              <a:t>ARI bootstrap = 0.98</a:t>
+              <a:t>Al repetir el análisis</a:t>
             </a:r>
             <a:br/>
             <a:r>
-              <a:t>(mín 0.95, 5 réplicas)</a:t>
+              <a:t>con datos remuestreados,</a:t>
             </a:r>
             <a:br/>
             <a:r>
-              <a:t>Entropía relativa: 0.78</a:t>
+              <a:t>los perfiles salen</a:t>
             </a:r>
             <a:br/>
             <a:r>
-              <a:t>69% asignación clara</a:t>
+              <a:t>casi idénticos</a:t>
+            </a:r>
+            <a:br/>
+            <a:r>
+              <a:t>(0.98 de 1).</a:t>
+            </a:r>
+            <a:br/>
+            <a:r>
+              <a:t>7 de cada 10 personas</a:t>
+            </a:r>
+            <a:br/>
+            <a:r>
+              <a:t>caen claramente</a:t>
+            </a:r>
+            <a:br/>
+            <a:r>
+              <a:t>en un perfil</a:t>
             </a:r>
           </a:p>
         </p:txBody>
@@ -5759,8 +5799,8 @@
         </p:nvSpPr>
         <p:spPr>
           <a:xfrm>
-            <a:off x="731520" y="4572000"/>
-            <a:ext cx="10515600" cy="1645920"/>
+            <a:off x="6583680" y="4343400"/>
+            <a:ext cx="4663440" cy="2240280"/>
           </a:xfrm>
           <a:prstGeom prst="rect">
             <a:avLst/>
@@ -5774,18 +5814,60 @@
           <a:lstStyle/>
           <a:p>
             <a:pPr algn="l">
-              <a:defRPr sz="1400" b="0">
+              <a:spcAft>
+                <a:spcPts val="576"/>
+              </a:spcAft>
+              <a:defRPr sz="1300" b="0">
                 <a:solidFill>
                   <a:srgbClr val="3C3C3C"/>
                 </a:solidFill>
               </a:defRPr>
             </a:pPr>
             <a:r>
-              <a:t>Ventaja clave: la discretización en terciles por elección normaliza el nivel y permite capturar simultáneamente el patrón temporal (brecha y tendencia). La demografía (edad, sexo, escolaridad, región) se usa como descriptor posterior, no como entrada: los perfiles emergen del comportamiento.</a:t>
-            </a:r>
-          </a:p>
-        </p:txBody>
-      </p:sp>
+              <a:t>Mismo promedio, historias opuestas. P1 y P2 votan alrededor de 50%, pero P1 va a la baja y P2 crece y se dispara en presidenciales. Necesitan estrategias distintas: el método debía ver la forma de la trayectoria, no solo el nivel.</a:t>
+            </a:r>
+          </a:p>
+          <a:p>
+            <a:pPr algn="l">
+              <a:spcAft>
+                <a:spcPts val="576"/>
+              </a:spcAft>
+              <a:defRPr sz="1300" b="0">
+                <a:solidFill>
+                  <a:srgbClr val="3C3C3C"/>
+                </a:solidFill>
+              </a:defRPr>
+            </a:pPr>
+            <a:r>
+              <a:t>Edad, sexo, escolaridad y región se usan después para describir los perfiles: al meterlas como entrada, el algoritmo solo separaba hombres de mujeres.</a:t>
+            </a:r>
+          </a:p>
+        </p:txBody>
+      </p:sp>
+      <p:pic>
+        <p:nvPicPr>
+          <p:cNvPr id="16" name="Picture 15" descr="trayectorias.png"/>
+          <p:cNvPicPr>
+            <a:picLocks noChangeAspect="1"/>
+          </p:cNvPicPr>
+          <p:nvPr/>
+        </p:nvPicPr>
+        <p:blipFill>
+          <a:blip r:embed="rId2"/>
+          <a:stretch>
+            <a:fillRect/>
+          </a:stretch>
+        </p:blipFill>
+        <p:spPr>
+          <a:xfrm>
+            <a:off x="731520" y="4343400"/>
+            <a:ext cx="5669280" cy="2240280"/>
+          </a:xfrm>
+          <a:prstGeom prst="rect">
+            <a:avLst/>
+          </a:prstGeom>
+        </p:spPr>
+      </p:pic>
     </p:spTree>
   </p:cSld>
   <p:clrMapOvr>
@@ -6035,7 +6117,7 @@
               </a:defRPr>
             </a:pPr>
             <a:r>
-              <a:t>Prom</a:t>
+              <a:t>Participación media</a:t>
             </a:r>
           </a:p>
         </p:txBody>
@@ -6105,7 +6187,7 @@
               </a:defRPr>
             </a:pPr>
             <a:r>
-              <a:t>Brecha</a:t>
+              <a:t>Extra en presidenciales</a:t>
             </a:r>
           </a:p>
         </p:txBody>
@@ -6140,7 +6222,7 @@
               </a:defRPr>
             </a:pPr>
             <a:r>
-              <a:t>+14.3</a:t>
+              <a:t>+14.3 pts</a:t>
             </a:r>
           </a:p>
         </p:txBody>
@@ -6175,7 +6257,7 @@
               </a:defRPr>
             </a:pPr>
             <a:r>
-              <a:t>Tend</a:t>
+              <a:t>Cambio por elección</a:t>
             </a:r>
           </a:p>
         </p:txBody>
@@ -6210,7 +6292,7 @@
               </a:defRPr>
             </a:pPr>
             <a:r>
-              <a:t>+1.1</a:t>
+              <a:t>+1.1 pts</a:t>
             </a:r>
           </a:p>
         </p:txBody>
@@ -6450,7 +6532,7 @@
               </a:defRPr>
             </a:pPr>
             <a:r>
-              <a:t>Prom</a:t>
+              <a:t>Participación media</a:t>
             </a:r>
           </a:p>
         </p:txBody>
@@ -6520,7 +6602,7 @@
               </a:defRPr>
             </a:pPr>
             <a:r>
-              <a:t>Brecha</a:t>
+              <a:t>Extra en presidenciales</a:t>
             </a:r>
           </a:p>
         </p:txBody>
@@ -6555,7 +6637,7 @@
               </a:defRPr>
             </a:pPr>
             <a:r>
-              <a:t>+7.6</a:t>
+              <a:t>+7.6 pts</a:t>
             </a:r>
           </a:p>
         </p:txBody>
@@ -6590,7 +6672,7 @@
               </a:defRPr>
             </a:pPr>
             <a:r>
-              <a:t>Tend</a:t>
+              <a:t>Cambio por elección</a:t>
             </a:r>
           </a:p>
         </p:txBody>
@@ -6625,7 +6707,7 @@
               </a:defRPr>
             </a:pPr>
             <a:r>
-              <a:t>-1.6</a:t>
+              <a:t>-1.6 pts</a:t>
             </a:r>
           </a:p>
         </p:txBody>
@@ -6660,7 +6742,7 @@
               </a:defRPr>
             </a:pPr>
             <a:r>
-              <a:t>Mixto género</a:t>
+              <a:t>56% hombres</a:t>
             </a:r>
             <a:br/>
             <a:r>
@@ -6865,7 +6947,7 @@
               </a:defRPr>
             </a:pPr>
             <a:r>
-              <a:t>Prom</a:t>
+              <a:t>Participación media</a:t>
             </a:r>
           </a:p>
         </p:txBody>
@@ -6935,7 +7017,7 @@
               </a:defRPr>
             </a:pPr>
             <a:r>
-              <a:t>Brecha</a:t>
+              <a:t>Extra en presidenciales</a:t>
             </a:r>
           </a:p>
         </p:txBody>
@@ -6970,7 +7052,7 @@
               </a:defRPr>
             </a:pPr>
             <a:r>
-              <a:t>+18.4</a:t>
+              <a:t>+18.4 pts</a:t>
             </a:r>
           </a:p>
         </p:txBody>
@@ -7005,7 +7087,7 @@
               </a:defRPr>
             </a:pPr>
             <a:r>
-              <a:t>Tend</a:t>
+              <a:t>Cambio por elección</a:t>
             </a:r>
           </a:p>
         </p:txBody>
@@ -7040,7 +7122,7 @@
               </a:defRPr>
             </a:pPr>
             <a:r>
-              <a:t>+3.0</a:t>
+              <a:t>+3.0 pts</a:t>
             </a:r>
           </a:p>
         </p:txBody>
@@ -7083,7 +7165,7 @@
             </a:r>
             <a:br/>
             <a:r>
-              <a:t>Urbano, digital</a:t>
+              <a:t>Urbano, más internet</a:t>
             </a:r>
           </a:p>
         </p:txBody>
@@ -7276,7 +7358,7 @@
               </a:defRPr>
             </a:pPr>
             <a:r>
-              <a:t>Prom</a:t>
+              <a:t>Participación media</a:t>
             </a:r>
           </a:p>
         </p:txBody>
@@ -7346,7 +7428,7 @@
               </a:defRPr>
             </a:pPr>
             <a:r>
-              <a:t>Brecha</a:t>
+              <a:t>Extra en presidenciales</a:t>
             </a:r>
           </a:p>
         </p:txBody>
@@ -7381,7 +7463,7 @@
               </a:defRPr>
             </a:pPr>
             <a:r>
-              <a:t>+9.3</a:t>
+              <a:t>+9.3 pts</a:t>
             </a:r>
           </a:p>
         </p:txBody>
@@ -7416,7 +7498,7 @@
               </a:defRPr>
             </a:pPr>
             <a:r>
-              <a:t>Tend</a:t>
+              <a:t>Cambio por elección</a:t>
             </a:r>
           </a:p>
         </p:txBody>
@@ -7451,7 +7533,7 @@
               </a:defRPr>
             </a:pPr>
             <a:r>
-              <a:t>-0.1</a:t>
+              <a:t>-0.1 pts</a:t>
             </a:r>
           </a:p>
         </p:txBody>
@@ -7691,7 +7773,7 @@
               </a:defRPr>
             </a:pPr>
             <a:r>
-              <a:t>Prom</a:t>
+              <a:t>Participación media</a:t>
             </a:r>
           </a:p>
         </p:txBody>
@@ -7761,7 +7843,7 @@
               </a:defRPr>
             </a:pPr>
             <a:r>
-              <a:t>Brecha</a:t>
+              <a:t>Extra en presidenciales</a:t>
             </a:r>
           </a:p>
         </p:txBody>
@@ -7796,7 +7878,7 @@
               </a:defRPr>
             </a:pPr>
             <a:r>
-              <a:t>+19.5</a:t>
+              <a:t>+19.5 pts</a:t>
             </a:r>
           </a:p>
         </p:txBody>
@@ -7831,7 +7913,7 @@
               </a:defRPr>
             </a:pPr>
             <a:r>
-              <a:t>Tend</a:t>
+              <a:t>Cambio por elección</a:t>
             </a:r>
           </a:p>
         </p:txBody>
@@ -7866,7 +7948,7 @@
               </a:defRPr>
             </a:pPr>
             <a:r>
-              <a:t>+4.5</a:t>
+              <a:t>+4.5 pts</a:t>
             </a:r>
           </a:p>
         </p:txBody>
@@ -7905,11 +7987,15 @@
             </a:r>
             <a:br/>
             <a:r>
-              <a:t>Mayor escolaridad</a:t>
+              <a:t>Zonas de mayor</a:t>
             </a:r>
             <a:br/>
             <a:r>
-              <a:t>Crecimiento máx</a:t>
+              <a:t>escolaridad</a:t>
+            </a:r>
+            <a:br/>
+            <a:r>
+              <a:t>Mayor crecimiento</a:t>
             </a:r>
           </a:p>
         </p:txBody>
@@ -8106,7 +8192,7 @@
               </a:defRPr>
             </a:pPr>
             <a:r>
-              <a:t>Prom</a:t>
+              <a:t>Participación media</a:t>
             </a:r>
           </a:p>
         </p:txBody>
@@ -8176,7 +8262,7 @@
               </a:defRPr>
             </a:pPr>
             <a:r>
-              <a:t>Brecha</a:t>
+              <a:t>Extra en presidenciales</a:t>
             </a:r>
           </a:p>
         </p:txBody>
@@ -8211,7 +8297,7 @@
               </a:defRPr>
             </a:pPr>
             <a:r>
-              <a:t>+10.6</a:t>
+              <a:t>+10.6 pts</a:t>
             </a:r>
           </a:p>
         </p:txBody>
@@ -8246,7 +8332,7 @@
               </a:defRPr>
             </a:pPr>
             <a:r>
-              <a:t>Tend</a:t>
+              <a:t>Cambio por elección</a:t>
             </a:r>
           </a:p>
         </p:txBody>
@@ -8281,7 +8367,7 @@
               </a:defRPr>
             </a:pPr>
             <a:r>
-              <a:t>+1.8</a:t>
+              <a:t>+1.8 pts</a:t>
             </a:r>
           </a:p>
         </p:txBody>
@@ -8324,7 +8410,7 @@
             </a:r>
             <a:br/>
             <a:r>
-              <a:t>Rural, indígena</a:t>
+              <a:t>El más rural</a:t>
             </a:r>
           </a:p>
         </p:txBody>
@@ -8499,7 +8585,7 @@
               </a:defRPr>
             </a:pPr>
             <a:r>
-              <a:t>P0 tiene solo 4-5% en municipios de alta marginación. Las zonas rurales e indígenas participan más que el promedio.</a:t>
+              <a:t>P0 tiene solo 4-5% de su población en municipios de alta marginación. Las zonas rurales e indígenas participan más que el promedio.</a:t>
             </a:r>
           </a:p>
         </p:txBody>
@@ -8727,7 +8813,7 @@
               </a:defRPr>
             </a:pPr>
             <a:r>
-              <a:t>63.1% vs 55.1% nacional. La diferencia es mayor en intermedias (hasta 13 puntos más). Se concentran en P5 y P4.</a:t>
+              <a:t>63.1% contra 55.1% del resto de las secciones. La diferencia es mayor en intermedias (hasta 13 puntos). Se concentran en P5 y P4.</a:t>
             </a:r>
           </a:p>
         </p:txBody>
@@ -8806,7 +8892,7 @@
               </a:defRPr>
             </a:pPr>
             <a:r>
-              <a:t>P1 es la alerta roja</a:t>
+              <a:t>P1 es la señal de alerta</a:t>
             </a:r>
           </a:p>
         </p:txBody>
@@ -8841,7 +8927,7 @@
               </a:defRPr>
             </a:pPr>
             <a:r>
-              <a:t>Único perfil en descenso (-1.6/elección). Baja claridad de asignación (44%). Sin intervención, 5.9M migrarán a P0.</a:t>
+              <a:t>Único perfil en descenso (-1.6 pts por elección). Solo 44% pertenece claramente al perfil: población en transición que podría derivar hacia P0.</a:t>
             </a:r>
           </a:p>
         </p:txBody>
@@ -13042,7 +13128,7 @@
               </a:defRPr>
             </a:pPr>
             <a:r>
-              <a:t>código abierto en repositorio con UV (entorno reproducible). 11 notebooks numerados, desde ingesta hasta visualización. Segmentación ejecutable en ~12 segundos.</a:t>
+              <a:t>Código abierto con entorno reproducible. 11 notebooks numerados, de la descarga de datos a las visualizaciones. La segmentación se ejecuta en ~12 segundos.</a:t>
             </a:r>
           </a:p>
         </p:txBody>
@@ -13270,7 +13356,7 @@
               </a:defRPr>
             </a:pPr>
             <a:r>
-              <a:t>Mapa folium con capas municipal y estatal, panel de perfiles con gráficos SVG comparativos. Explorable por cualquier funcionario del INE sin software especial.</a:t>
+              <a:t>Mapa web con capas municipal y estatal y panel comparativo de perfiles. Se abre en cualquier navegador, sin software especial.</a:t>
             </a:r>
           </a:p>
         </p:txBody>
@@ -13498,7 +13584,7 @@
               </a:defRPr>
             </a:pPr>
             <a:r>
-              <a:t>Microtargeting territorial: cada subperfil con municipio dominante, entidad de sobrerrepresentación y persona-tipo (sexo x edad).</a:t>
+              <a:t>Focalización territorial: cada subperfil con su municipio dominante, entidades donde está sobrerrepresentado y combinación típica de sexo y edad.</a:t>
             </a:r>
           </a:p>
         </p:txBody>

</xml_diff>